<commit_message>
Fix slide layout feedback
</commit_message>
<xml_diff>
--- a/第5回_Multi-Head_Attention/excel_multi_head_attention_slides.pptx
+++ b/第5回_Multi-Head_Attention/excel_multi_head_attention_slides.pptx
@@ -10281,7 +10281,7 @@
         </p:nvSpPr>
         <p:spPr>
           <a:xfrm>
-            <a:off x="4572000" y="1417320"/>
+            <a:off x="4572000" y="2057400"/>
             <a:ext cx="2651760" cy="914400"/>
           </a:xfrm>
           <a:prstGeom prst="roundRect">
@@ -10351,7 +10351,7 @@
         </p:nvSpPr>
         <p:spPr>
           <a:xfrm>
-            <a:off x="4572000" y="2606040"/>
+            <a:off x="4572000" y="2926080"/>
             <a:ext cx="2651760" cy="914400"/>
           </a:xfrm>
           <a:prstGeom prst="roundRect">
@@ -10421,7 +10421,7 @@
         </p:nvCxnSpPr>
         <p:spPr>
           <a:xfrm>
-            <a:off x="7269480" y="1920240"/>
+            <a:off x="7269480" y="2560320"/>
             <a:ext cx="731520" cy="365760"/>
           </a:xfrm>
           <a:prstGeom prst="line">
@@ -10456,7 +10456,7 @@
         </p:nvCxnSpPr>
         <p:spPr>
           <a:xfrm flipV="1">
-            <a:off x="7269480" y="2651760"/>
+            <a:off x="7269480" y="2971800"/>
             <a:ext cx="731520" cy="411480"/>
           </a:xfrm>
           <a:prstGeom prst="line">
@@ -10491,7 +10491,7 @@
         </p:nvSpPr>
         <p:spPr>
           <a:xfrm>
-            <a:off x="8001000" y="2011680"/>
+            <a:off x="8001000" y="2651760"/>
             <a:ext cx="2788920" cy="1051560"/>
           </a:xfrm>
           <a:prstGeom prst="roundRect">

</xml_diff>